<commit_message>
Add single-page recreation slide matching the source image
Slide 11 reproduces the original layout on one page: title with underline,
center wheel diagram (TSMC core, color-banded ring, seven team labels),
Execution / Core Support / Business pills with connectors, and the bottom
Global Collaboration Network bar with five region cells.

https://claude.ai/code/session_01Mp1t9t7A5TDtsPLuQYgFuJ
</commit_message>
<xml_diff>
--- a/Functional_Team_Collaboration.pptx
+++ b/Functional_Team_Collaboration.pptx
@@ -15,6 +15,7 @@
     <p:sldId id="263" r:id="rId14"/>
     <p:sldId id="264" r:id="rId15"/>
     <p:sldId id="265" r:id="rId16"/>
+    <p:sldId id="266" r:id="rId17"/>
   </p:sldIdLst>
   <p:sldSz cx="12191695" cy="6858000" type="screen4x3"/>
   <p:notesSz cx="6858000" cy="9144000"/>
@@ -3721,6 +3722,2097 @@
               <a:rPr sz="1000" b="0">
                 <a:solidFill>
                   <a:srgbClr val="BFD8EF"/>
+                </a:solidFill>
+                <a:latin typeface="Calibri"/>
+              </a:rPr>
+              <a:t>© 2026 Eaton. All rights reserved.</a:t>
+            </a:r>
+          </a:p>
+        </p:txBody>
+      </p:sp>
+    </p:spTree>
+  </p:cSld>
+  <p:clrMapOvr>
+    <a:masterClrMapping/>
+  </p:clrMapOvr>
+</p:sld>
+</file>
+
+<file path=ppt/slides/slide11.xml><?xml version="1.0" encoding="utf-8"?>
+<p:sld xmlns:a="http://schemas.openxmlformats.org/drawingml/2006/main" xmlns:p="http://schemas.openxmlformats.org/presentationml/2006/main" xmlns:r="http://schemas.openxmlformats.org/officeDocument/2006/relationships">
+  <p:cSld>
+    <p:spTree>
+      <p:nvGrpSpPr>
+        <p:cNvPr id="1" name=""/>
+        <p:cNvGrpSpPr/>
+        <p:nvPr/>
+      </p:nvGrpSpPr>
+      <p:grpSpPr/>
+      <p:sp>
+        <p:nvSpPr>
+          <p:cNvPr id="2" name="Rectangle 1"/>
+          <p:cNvSpPr/>
+          <p:nvPr/>
+        </p:nvSpPr>
+        <p:spPr>
+          <a:xfrm>
+            <a:off x="0" y="0"/>
+            <a:ext cx="12191695" cy="6858000"/>
+          </a:xfrm>
+          <a:prstGeom prst="rect">
+            <a:avLst/>
+          </a:prstGeom>
+          <a:solidFill>
+            <a:srgbClr val="FFFFFF"/>
+          </a:solidFill>
+          <a:ln>
+            <a:noFill/>
+          </a:ln>
+          <a:effectLst/>
+        </p:spPr>
+        <p:style>
+          <a:lnRef idx="1">
+            <a:schemeClr val="accent1"/>
+          </a:lnRef>
+          <a:fillRef idx="3">
+            <a:schemeClr val="accent1"/>
+          </a:fillRef>
+          <a:effectRef idx="2">
+            <a:schemeClr val="accent1"/>
+          </a:effectRef>
+          <a:fontRef idx="minor">
+            <a:schemeClr val="lt1"/>
+          </a:fontRef>
+        </p:style>
+        <p:txBody>
+          <a:bodyPr rtlCol="0" anchor="ctr"/>
+          <a:lstStyle/>
+          <a:p>
+            <a:pPr algn="ctr"/>
+          </a:p>
+        </p:txBody>
+      </p:sp>
+      <p:sp>
+        <p:nvSpPr>
+          <p:cNvPr id="3" name="Rectangle 2"/>
+          <p:cNvSpPr/>
+          <p:nvPr/>
+        </p:nvSpPr>
+        <p:spPr>
+          <a:xfrm>
+            <a:off x="0" y="0"/>
+            <a:ext cx="12191695" cy="164592"/>
+          </a:xfrm>
+          <a:prstGeom prst="rect">
+            <a:avLst/>
+          </a:prstGeom>
+          <a:solidFill>
+            <a:srgbClr val="0B2C5C"/>
+          </a:solidFill>
+          <a:ln>
+            <a:noFill/>
+          </a:ln>
+          <a:effectLst/>
+        </p:spPr>
+        <p:style>
+          <a:lnRef idx="1">
+            <a:schemeClr val="accent1"/>
+          </a:lnRef>
+          <a:fillRef idx="3">
+            <a:schemeClr val="accent1"/>
+          </a:fillRef>
+          <a:effectRef idx="2">
+            <a:schemeClr val="accent1"/>
+          </a:effectRef>
+          <a:fontRef idx="minor">
+            <a:schemeClr val="lt1"/>
+          </a:fontRef>
+        </p:style>
+        <p:txBody>
+          <a:bodyPr rtlCol="0" anchor="ctr"/>
+          <a:lstStyle/>
+          <a:p>
+            <a:pPr algn="ctr"/>
+          </a:p>
+        </p:txBody>
+      </p:sp>
+      <p:sp>
+        <p:nvSpPr>
+          <p:cNvPr id="4" name="Rectangle 3"/>
+          <p:cNvSpPr/>
+          <p:nvPr/>
+        </p:nvSpPr>
+        <p:spPr>
+          <a:xfrm>
+            <a:off x="0" y="6693408"/>
+            <a:ext cx="12191695" cy="164592"/>
+          </a:xfrm>
+          <a:prstGeom prst="rect">
+            <a:avLst/>
+          </a:prstGeom>
+          <a:solidFill>
+            <a:srgbClr val="0B2C5C"/>
+          </a:solidFill>
+          <a:ln>
+            <a:noFill/>
+          </a:ln>
+          <a:effectLst/>
+        </p:spPr>
+        <p:style>
+          <a:lnRef idx="1">
+            <a:schemeClr val="accent1"/>
+          </a:lnRef>
+          <a:fillRef idx="3">
+            <a:schemeClr val="accent1"/>
+          </a:fillRef>
+          <a:effectRef idx="2">
+            <a:schemeClr val="accent1"/>
+          </a:effectRef>
+          <a:fontRef idx="minor">
+            <a:schemeClr val="lt1"/>
+          </a:fontRef>
+        </p:style>
+        <p:txBody>
+          <a:bodyPr rtlCol="0" anchor="ctr"/>
+          <a:lstStyle/>
+          <a:p>
+            <a:pPr algn="ctr"/>
+          </a:p>
+        </p:txBody>
+      </p:sp>
+      <p:sp>
+        <p:nvSpPr>
+          <p:cNvPr id="5" name="TextBox 4"/>
+          <p:cNvSpPr txBox="1"/>
+          <p:nvPr/>
+        </p:nvSpPr>
+        <p:spPr>
+          <a:xfrm>
+            <a:off x="365760" y="274320"/>
+            <a:ext cx="7315200" cy="548640"/>
+          </a:xfrm>
+          <a:prstGeom prst="rect">
+            <a:avLst/>
+          </a:prstGeom>
+          <a:noFill/>
+        </p:spPr>
+        <p:txBody>
+          <a:bodyPr wrap="square" anchor="t" lIns="45720" rIns="45720" tIns="18288" bIns="18288">
+            <a:spAutoFit/>
+          </a:bodyPr>
+          <a:lstStyle/>
+          <a:p>
+            <a:pPr algn="l"/>
+            <a:r>
+              <a:rPr sz="3000" b="1">
+                <a:solidFill>
+                  <a:srgbClr val="0B2C5C"/>
+                </a:solidFill>
+                <a:latin typeface="Calibri"/>
+              </a:rPr>
+              <a:t>Functional Team Collaboration</a:t>
+            </a:r>
+          </a:p>
+        </p:txBody>
+      </p:sp>
+      <p:sp>
+        <p:nvSpPr>
+          <p:cNvPr id="6" name="Rectangle 5"/>
+          <p:cNvSpPr/>
+          <p:nvPr/>
+        </p:nvSpPr>
+        <p:spPr>
+          <a:xfrm>
+            <a:off x="365760" y="841248"/>
+            <a:ext cx="6858000" cy="15000"/>
+          </a:xfrm>
+          <a:prstGeom prst="rect">
+            <a:avLst/>
+          </a:prstGeom>
+          <a:solidFill>
+            <a:srgbClr val="0B2C5C"/>
+          </a:solidFill>
+          <a:ln>
+            <a:noFill/>
+          </a:ln>
+          <a:effectLst/>
+        </p:spPr>
+        <p:style>
+          <a:lnRef idx="1">
+            <a:schemeClr val="accent1"/>
+          </a:lnRef>
+          <a:fillRef idx="3">
+            <a:schemeClr val="accent1"/>
+          </a:fillRef>
+          <a:effectRef idx="2">
+            <a:schemeClr val="accent1"/>
+          </a:effectRef>
+          <a:fontRef idx="minor">
+            <a:schemeClr val="lt1"/>
+          </a:fontRef>
+        </p:style>
+        <p:txBody>
+          <a:bodyPr rtlCol="0" anchor="ctr"/>
+          <a:lstStyle/>
+          <a:p>
+            <a:pPr algn="ctr"/>
+          </a:p>
+        </p:txBody>
+      </p:sp>
+      <p:sp>
+        <p:nvSpPr>
+          <p:cNvPr id="7" name="TextBox 6"/>
+          <p:cNvSpPr txBox="1"/>
+          <p:nvPr/>
+        </p:nvSpPr>
+        <p:spPr>
+          <a:xfrm>
+            <a:off x="365760" y="868680"/>
+            <a:ext cx="7315200" cy="365760"/>
+          </a:xfrm>
+          <a:prstGeom prst="rect">
+            <a:avLst/>
+          </a:prstGeom>
+          <a:noFill/>
+        </p:spPr>
+        <p:txBody>
+          <a:bodyPr wrap="square" anchor="t" lIns="45720" rIns="45720" tIns="18288" bIns="18288">
+            <a:spAutoFit/>
+          </a:bodyPr>
+          <a:lstStyle/>
+          <a:p>
+            <a:pPr algn="l"/>
+            <a:r>
+              <a:rPr sz="1400" b="0">
+                <a:solidFill>
+                  <a:srgbClr val="1F2A44"/>
+                </a:solidFill>
+                <a:latin typeface="Calibri"/>
+              </a:rPr>
+              <a:t>One Goal – Delivering Excellence for TSMC</a:t>
+            </a:r>
+          </a:p>
+        </p:txBody>
+      </p:sp>
+      <p:sp>
+        <p:nvSpPr>
+          <p:cNvPr id="8" name="Oval 7"/>
+          <p:cNvSpPr/>
+          <p:nvPr/>
+        </p:nvSpPr>
+        <p:spPr>
+          <a:xfrm>
+            <a:off x="4221328" y="1783081"/>
+            <a:ext cx="3749038" cy="3749038"/>
+          </a:xfrm>
+          <a:prstGeom prst="ellipse">
+            <a:avLst/>
+          </a:prstGeom>
+          <a:solidFill>
+            <a:srgbClr val="BFD8EF"/>
+          </a:solidFill>
+          <a:ln w="25400">
+            <a:solidFill>
+              <a:srgbClr val="FFFFFF"/>
+            </a:solidFill>
+          </a:ln>
+          <a:effectLst/>
+        </p:spPr>
+        <p:style>
+          <a:lnRef idx="1">
+            <a:schemeClr val="accent1"/>
+          </a:lnRef>
+          <a:fillRef idx="3">
+            <a:schemeClr val="accent1"/>
+          </a:fillRef>
+          <a:effectRef idx="2">
+            <a:schemeClr val="accent1"/>
+          </a:effectRef>
+          <a:fontRef idx="minor">
+            <a:schemeClr val="lt1"/>
+          </a:fontRef>
+        </p:style>
+        <p:txBody>
+          <a:bodyPr rtlCol="0" anchor="ctr"/>
+          <a:lstStyle/>
+          <a:p>
+            <a:pPr algn="ctr"/>
+          </a:p>
+        </p:txBody>
+      </p:sp>
+      <p:sp>
+        <p:nvSpPr>
+          <p:cNvPr id="9" name="Pie 8"/>
+          <p:cNvSpPr/>
+          <p:nvPr/>
+        </p:nvSpPr>
+        <p:spPr>
+          <a:xfrm>
+            <a:off x="4221328" y="1783081"/>
+            <a:ext cx="3749038" cy="3749038"/>
+          </a:xfrm>
+          <a:prstGeom prst="pie">
+            <a:avLst>
+              <a:gd name="adj1" fmla="val -9000000"/>
+              <a:gd name="adj2" fmla="val 3000000"/>
+            </a:avLst>
+          </a:prstGeom>
+          <a:solidFill>
+            <a:srgbClr val="124A9C"/>
+          </a:solidFill>
+          <a:ln>
+            <a:noFill/>
+          </a:ln>
+          <a:effectLst/>
+        </p:spPr>
+        <p:style>
+          <a:lnRef idx="1">
+            <a:schemeClr val="accent1"/>
+          </a:lnRef>
+          <a:fillRef idx="3">
+            <a:schemeClr val="accent1"/>
+          </a:fillRef>
+          <a:effectRef idx="2">
+            <a:schemeClr val="accent1"/>
+          </a:effectRef>
+          <a:fontRef idx="minor">
+            <a:schemeClr val="lt1"/>
+          </a:fontRef>
+        </p:style>
+        <p:txBody>
+          <a:bodyPr rtlCol="0" anchor="ctr"/>
+          <a:lstStyle/>
+          <a:p>
+            <a:pPr algn="ctr"/>
+          </a:p>
+        </p:txBody>
+      </p:sp>
+      <p:sp>
+        <p:nvSpPr>
+          <p:cNvPr id="10" name="Pie 9"/>
+          <p:cNvSpPr/>
+          <p:nvPr/>
+        </p:nvSpPr>
+        <p:spPr>
+          <a:xfrm>
+            <a:off x="4221328" y="1783081"/>
+            <a:ext cx="3749038" cy="3749038"/>
+          </a:xfrm>
+          <a:prstGeom prst="pie">
+            <a:avLst>
+              <a:gd name="adj1" fmla="val 3000000"/>
+              <a:gd name="adj2" fmla="val 15000000"/>
+            </a:avLst>
+          </a:prstGeom>
+          <a:solidFill>
+            <a:srgbClr val="4A90D9"/>
+          </a:solidFill>
+          <a:ln>
+            <a:noFill/>
+          </a:ln>
+          <a:effectLst/>
+        </p:spPr>
+        <p:style>
+          <a:lnRef idx="1">
+            <a:schemeClr val="accent1"/>
+          </a:lnRef>
+          <a:fillRef idx="3">
+            <a:schemeClr val="accent1"/>
+          </a:fillRef>
+          <a:effectRef idx="2">
+            <a:schemeClr val="accent1"/>
+          </a:effectRef>
+          <a:fontRef idx="minor">
+            <a:schemeClr val="lt1"/>
+          </a:fontRef>
+        </p:style>
+        <p:txBody>
+          <a:bodyPr rtlCol="0" anchor="ctr"/>
+          <a:lstStyle/>
+          <a:p>
+            <a:pPr algn="ctr"/>
+          </a:p>
+        </p:txBody>
+      </p:sp>
+      <p:sp>
+        <p:nvSpPr>
+          <p:cNvPr id="11" name="Pie 10"/>
+          <p:cNvSpPr/>
+          <p:nvPr/>
+        </p:nvSpPr>
+        <p:spPr>
+          <a:xfrm>
+            <a:off x="4221328" y="1783081"/>
+            <a:ext cx="3749038" cy="3749038"/>
+          </a:xfrm>
+          <a:prstGeom prst="pie">
+            <a:avLst>
+              <a:gd name="adj1" fmla="val 15000000"/>
+              <a:gd name="adj2" fmla="val 27000000"/>
+            </a:avLst>
+          </a:prstGeom>
+          <a:solidFill>
+            <a:srgbClr val="1E6FB8"/>
+          </a:solidFill>
+          <a:ln>
+            <a:noFill/>
+          </a:ln>
+          <a:effectLst/>
+        </p:spPr>
+        <p:style>
+          <a:lnRef idx="1">
+            <a:schemeClr val="accent1"/>
+          </a:lnRef>
+          <a:fillRef idx="3">
+            <a:schemeClr val="accent1"/>
+          </a:fillRef>
+          <a:effectRef idx="2">
+            <a:schemeClr val="accent1"/>
+          </a:effectRef>
+          <a:fontRef idx="minor">
+            <a:schemeClr val="lt1"/>
+          </a:fontRef>
+        </p:style>
+        <p:txBody>
+          <a:bodyPr rtlCol="0" anchor="ctr"/>
+          <a:lstStyle/>
+          <a:p>
+            <a:pPr algn="ctr"/>
+          </a:p>
+        </p:txBody>
+      </p:sp>
+      <p:sp>
+        <p:nvSpPr>
+          <p:cNvPr id="12" name="Oval 11"/>
+          <p:cNvSpPr/>
+          <p:nvPr/>
+        </p:nvSpPr>
+        <p:spPr>
+          <a:xfrm>
+            <a:off x="5090007" y="2651760"/>
+            <a:ext cx="2011680" cy="2011680"/>
+          </a:xfrm>
+          <a:prstGeom prst="ellipse">
+            <a:avLst/>
+          </a:prstGeom>
+          <a:solidFill>
+            <a:srgbClr val="FFFFFF"/>
+          </a:solidFill>
+          <a:ln>
+            <a:noFill/>
+          </a:ln>
+          <a:effectLst/>
+        </p:spPr>
+        <p:style>
+          <a:lnRef idx="1">
+            <a:schemeClr val="accent1"/>
+          </a:lnRef>
+          <a:fillRef idx="3">
+            <a:schemeClr val="accent1"/>
+          </a:fillRef>
+          <a:effectRef idx="2">
+            <a:schemeClr val="accent1"/>
+          </a:effectRef>
+          <a:fontRef idx="minor">
+            <a:schemeClr val="lt1"/>
+          </a:fontRef>
+        </p:style>
+        <p:txBody>
+          <a:bodyPr rtlCol="0" anchor="ctr"/>
+          <a:lstStyle/>
+          <a:p>
+            <a:pPr algn="ctr"/>
+          </a:p>
+        </p:txBody>
+      </p:sp>
+      <p:sp>
+        <p:nvSpPr>
+          <p:cNvPr id="13" name="Oval 12"/>
+          <p:cNvSpPr/>
+          <p:nvPr/>
+        </p:nvSpPr>
+        <p:spPr>
+          <a:xfrm>
+            <a:off x="5227167" y="2788920"/>
+            <a:ext cx="1737360" cy="1737360"/>
+          </a:xfrm>
+          <a:prstGeom prst="ellipse">
+            <a:avLst/>
+          </a:prstGeom>
+          <a:solidFill>
+            <a:srgbClr val="FFFFFF"/>
+          </a:solidFill>
+          <a:ln w="25400">
+            <a:solidFill>
+              <a:srgbClr val="124A9C"/>
+            </a:solidFill>
+          </a:ln>
+          <a:effectLst/>
+        </p:spPr>
+        <p:style>
+          <a:lnRef idx="1">
+            <a:schemeClr val="accent1"/>
+          </a:lnRef>
+          <a:fillRef idx="3">
+            <a:schemeClr val="accent1"/>
+          </a:fillRef>
+          <a:effectRef idx="2">
+            <a:schemeClr val="accent1"/>
+          </a:effectRef>
+          <a:fontRef idx="minor">
+            <a:schemeClr val="lt1"/>
+          </a:fontRef>
+        </p:style>
+        <p:txBody>
+          <a:bodyPr rtlCol="0" anchor="ctr"/>
+          <a:lstStyle/>
+          <a:p>
+            <a:pPr algn="ctr"/>
+            <a:r>
+              <a:rPr sz="1400" b="1">
+                <a:solidFill>
+                  <a:srgbClr val="E01E1E"/>
+                </a:solidFill>
+              </a:rPr>
+              <a:t>tsmc</a:t>
+            </a:r>
+          </a:p>
+          <a:p>
+            <a:pPr algn="ctr"/>
+            <a:r>
+              <a:rPr sz="1600" b="1">
+                <a:solidFill>
+                  <a:srgbClr val="0B2C5C"/>
+                </a:solidFill>
+              </a:rPr>
+              <a:t>TSMC</a:t>
+            </a:r>
+          </a:p>
+          <a:p>
+            <a:pPr algn="ctr"/>
+            <a:r>
+              <a:rPr sz="1100">
+                <a:solidFill>
+                  <a:srgbClr val="0B2C5C"/>
+                </a:solidFill>
+              </a:rPr>
+              <a:t>Project</a:t>
+            </a:r>
+          </a:p>
+          <a:p>
+            <a:pPr algn="ctr"/>
+            <a:r>
+              <a:rPr sz="1100" b="1">
+                <a:solidFill>
+                  <a:srgbClr val="0B2C5C"/>
+                </a:solidFill>
+              </a:rPr>
+              <a:t>Core Team</a:t>
+            </a:r>
+          </a:p>
+        </p:txBody>
+      </p:sp>
+      <p:sp>
+        <p:nvSpPr>
+          <p:cNvPr id="14" name="TextBox 13"/>
+          <p:cNvSpPr txBox="1"/>
+          <p:nvPr/>
+        </p:nvSpPr>
+        <p:spPr>
+          <a:xfrm>
+            <a:off x="3545734" y="2000140"/>
+            <a:ext cx="1280160" cy="640080"/>
+          </a:xfrm>
+          <a:prstGeom prst="rect">
+            <a:avLst/>
+          </a:prstGeom>
+          <a:noFill/>
+        </p:spPr>
+        <p:txBody>
+          <a:bodyPr wrap="square" anchor="ctr">
+            <a:spAutoFit/>
+          </a:bodyPr>
+          <a:lstStyle/>
+          <a:p>
+            <a:pPr algn="ctr"/>
+            <a:r>
+              <a:rPr sz="1000" b="1">
+                <a:solidFill>
+                  <a:srgbClr val="124A9C"/>
+                </a:solidFill>
+              </a:rPr>
+              <a:t>APAC R&amp;D</a:t>
+            </a:r>
+          </a:p>
+          <a:p>
+            <a:pPr algn="ctr"/>
+            <a:r>
+              <a:rPr sz="1000" b="1">
+                <a:solidFill>
+                  <a:srgbClr val="124A9C"/>
+                </a:solidFill>
+              </a:rPr>
+              <a:t>Service Team</a:t>
+            </a:r>
+          </a:p>
+        </p:txBody>
+      </p:sp>
+      <p:sp>
+        <p:nvSpPr>
+          <p:cNvPr id="15" name="TextBox 14"/>
+          <p:cNvSpPr txBox="1"/>
+          <p:nvPr/>
+        </p:nvSpPr>
+        <p:spPr>
+          <a:xfrm>
+            <a:off x="5252544" y="1014712"/>
+            <a:ext cx="1280160" cy="640080"/>
+          </a:xfrm>
+          <a:prstGeom prst="rect">
+            <a:avLst/>
+          </a:prstGeom>
+          <a:noFill/>
+        </p:spPr>
+        <p:txBody>
+          <a:bodyPr wrap="square" anchor="ctr">
+            <a:spAutoFit/>
+          </a:bodyPr>
+          <a:lstStyle/>
+          <a:p>
+            <a:pPr algn="ctr"/>
+            <a:r>
+              <a:rPr sz="1000" b="1">
+                <a:solidFill>
+                  <a:srgbClr val="4A90D9"/>
+                </a:solidFill>
+              </a:rPr>
+              <a:t>Technical</a:t>
+            </a:r>
+          </a:p>
+          <a:p>
+            <a:pPr algn="ctr"/>
+            <a:r>
+              <a:rPr sz="1000" b="1">
+                <a:solidFill>
+                  <a:srgbClr val="4A90D9"/>
+                </a:solidFill>
+              </a:rPr>
+              <a:t>Support Team</a:t>
+            </a:r>
+          </a:p>
+        </p:txBody>
+      </p:sp>
+      <p:sp>
+        <p:nvSpPr>
+          <p:cNvPr id="16" name="TextBox 15"/>
+          <p:cNvSpPr txBox="1"/>
+          <p:nvPr/>
+        </p:nvSpPr>
+        <p:spPr>
+          <a:xfrm>
+            <a:off x="7365800" y="2000140"/>
+            <a:ext cx="1280160" cy="640080"/>
+          </a:xfrm>
+          <a:prstGeom prst="rect">
+            <a:avLst/>
+          </a:prstGeom>
+          <a:noFill/>
+        </p:spPr>
+        <p:txBody>
+          <a:bodyPr wrap="square" anchor="ctr">
+            <a:spAutoFit/>
+          </a:bodyPr>
+          <a:lstStyle/>
+          <a:p>
+            <a:pPr algn="ctr"/>
+            <a:r>
+              <a:rPr sz="1000" b="1">
+                <a:solidFill>
+                  <a:srgbClr val="4A90D9"/>
+                </a:solidFill>
+              </a:rPr>
+              <a:t>Customer</a:t>
+            </a:r>
+          </a:p>
+          <a:p>
+            <a:pPr algn="ctr"/>
+            <a:r>
+              <a:rPr sz="1000" b="1">
+                <a:solidFill>
+                  <a:srgbClr val="4A90D9"/>
+                </a:solidFill>
+              </a:rPr>
+              <a:t>Service</a:t>
+            </a:r>
+          </a:p>
+          <a:p>
+            <a:pPr algn="ctr"/>
+            <a:r>
+              <a:rPr sz="1000" b="1">
+                <a:solidFill>
+                  <a:srgbClr val="4A90D9"/>
+                </a:solidFill>
+              </a:rPr>
+              <a:t>Team</a:t>
+            </a:r>
+          </a:p>
+        </p:txBody>
+      </p:sp>
+      <p:sp>
+        <p:nvSpPr>
+          <p:cNvPr id="17" name="TextBox 16"/>
+          <p:cNvSpPr txBox="1"/>
+          <p:nvPr/>
+        </p:nvSpPr>
+        <p:spPr>
+          <a:xfrm>
+            <a:off x="7646867" y="4135055"/>
+            <a:ext cx="1280160" cy="640080"/>
+          </a:xfrm>
+          <a:prstGeom prst="rect">
+            <a:avLst/>
+          </a:prstGeom>
+          <a:noFill/>
+        </p:spPr>
+        <p:txBody>
+          <a:bodyPr wrap="square" anchor="ctr">
+            <a:spAutoFit/>
+          </a:bodyPr>
+          <a:lstStyle/>
+          <a:p>
+            <a:pPr algn="ctr"/>
+            <a:r>
+              <a:rPr sz="1000" b="1">
+                <a:solidFill>
+                  <a:srgbClr val="1E6FB8"/>
+                </a:solidFill>
+              </a:rPr>
+              <a:t>Sales</a:t>
+            </a:r>
+          </a:p>
+          <a:p>
+            <a:pPr algn="ctr"/>
+            <a:r>
+              <a:rPr sz="1000" b="1">
+                <a:solidFill>
+                  <a:srgbClr val="1E6FB8"/>
+                </a:solidFill>
+              </a:rPr>
+              <a:t>Team</a:t>
+            </a:r>
+          </a:p>
+        </p:txBody>
+      </p:sp>
+      <p:sp>
+        <p:nvSpPr>
+          <p:cNvPr id="18" name="TextBox 17"/>
+          <p:cNvSpPr txBox="1"/>
+          <p:nvPr/>
+        </p:nvSpPr>
+        <p:spPr>
+          <a:xfrm>
+            <a:off x="5658990" y="5660407"/>
+            <a:ext cx="1280160" cy="640080"/>
+          </a:xfrm>
+          <a:prstGeom prst="rect">
+            <a:avLst/>
+          </a:prstGeom>
+          <a:noFill/>
+        </p:spPr>
+        <p:txBody>
+          <a:bodyPr wrap="square" anchor="ctr">
+            <a:spAutoFit/>
+          </a:bodyPr>
+          <a:lstStyle/>
+          <a:p>
+            <a:pPr algn="ctr"/>
+            <a:r>
+              <a:rPr sz="1000" b="1">
+                <a:solidFill>
+                  <a:srgbClr val="1E6FB8"/>
+                </a:solidFill>
+              </a:rPr>
+              <a:t>SCM Team</a:t>
+            </a:r>
+          </a:p>
+        </p:txBody>
+      </p:sp>
+      <p:sp>
+        <p:nvSpPr>
+          <p:cNvPr id="19" name="TextBox 18"/>
+          <p:cNvSpPr txBox="1"/>
+          <p:nvPr/>
+        </p:nvSpPr>
+        <p:spPr>
+          <a:xfrm>
+            <a:off x="3545734" y="4674979"/>
+            <a:ext cx="1280160" cy="640080"/>
+          </a:xfrm>
+          <a:prstGeom prst="rect">
+            <a:avLst/>
+          </a:prstGeom>
+          <a:noFill/>
+        </p:spPr>
+        <p:txBody>
+          <a:bodyPr wrap="square" anchor="ctr">
+            <a:spAutoFit/>
+          </a:bodyPr>
+          <a:lstStyle/>
+          <a:p>
+            <a:pPr algn="ctr"/>
+            <a:r>
+              <a:rPr sz="1000" b="1">
+                <a:solidFill>
+                  <a:srgbClr val="1E6FB8"/>
+                </a:solidFill>
+              </a:rPr>
+              <a:t>Factory</a:t>
+            </a:r>
+          </a:p>
+          <a:p>
+            <a:pPr algn="ctr"/>
+            <a:r>
+              <a:rPr sz="1000" b="1">
+                <a:solidFill>
+                  <a:srgbClr val="1E6FB8"/>
+                </a:solidFill>
+              </a:rPr>
+              <a:t>Unit Team</a:t>
+            </a:r>
+          </a:p>
+        </p:txBody>
+      </p:sp>
+      <p:sp>
+        <p:nvSpPr>
+          <p:cNvPr id="20" name="TextBox 19"/>
+          <p:cNvSpPr txBox="1"/>
+          <p:nvPr/>
+        </p:nvSpPr>
+        <p:spPr>
+          <a:xfrm>
+            <a:off x="5252544" y="5660407"/>
+            <a:ext cx="1280160" cy="640080"/>
+          </a:xfrm>
+          <a:prstGeom prst="rect">
+            <a:avLst/>
+          </a:prstGeom>
+          <a:noFill/>
+        </p:spPr>
+        <p:txBody>
+          <a:bodyPr wrap="square" anchor="ctr">
+            <a:spAutoFit/>
+          </a:bodyPr>
+          <a:lstStyle/>
+          <a:p>
+            <a:pPr algn="ctr"/>
+            <a:r>
+              <a:rPr sz="1000" b="1">
+                <a:solidFill>
+                  <a:srgbClr val="124A9C"/>
+                </a:solidFill>
+              </a:rPr>
+              <a:t>Project</a:t>
+            </a:r>
+          </a:p>
+          <a:p>
+            <a:pPr algn="ctr"/>
+            <a:r>
+              <a:rPr sz="1000" b="1">
+                <a:solidFill>
+                  <a:srgbClr val="124A9C"/>
+                </a:solidFill>
+              </a:rPr>
+              <a:t>Management</a:t>
+            </a:r>
+          </a:p>
+          <a:p>
+            <a:pPr algn="ctr"/>
+            <a:r>
+              <a:rPr sz="1000" b="1">
+                <a:solidFill>
+                  <a:srgbClr val="124A9C"/>
+                </a:solidFill>
+              </a:rPr>
+              <a:t>Team</a:t>
+            </a:r>
+          </a:p>
+        </p:txBody>
+      </p:sp>
+      <p:sp>
+        <p:nvSpPr>
+          <p:cNvPr id="21" name="Rounded Rectangle 20"/>
+          <p:cNvSpPr/>
+          <p:nvPr/>
+        </p:nvSpPr>
+        <p:spPr>
+          <a:xfrm>
+            <a:off x="5090007" y="1371600"/>
+            <a:ext cx="2011680" cy="365760"/>
+          </a:xfrm>
+          <a:prstGeom prst="roundRect">
+            <a:avLst/>
+          </a:prstGeom>
+          <a:solidFill>
+            <a:srgbClr val="0B2C5C"/>
+          </a:solidFill>
+          <a:ln>
+            <a:noFill/>
+          </a:ln>
+          <a:effectLst/>
+        </p:spPr>
+        <p:style>
+          <a:lnRef idx="1">
+            <a:schemeClr val="accent1"/>
+          </a:lnRef>
+          <a:fillRef idx="3">
+            <a:schemeClr val="accent1"/>
+          </a:fillRef>
+          <a:effectRef idx="2">
+            <a:schemeClr val="accent1"/>
+          </a:effectRef>
+          <a:fontRef idx="minor">
+            <a:schemeClr val="lt1"/>
+          </a:fontRef>
+        </p:style>
+        <p:txBody>
+          <a:bodyPr rtlCol="0" anchor="ctr" lIns="73152" rIns="73152" tIns="36576" bIns="36576"/>
+          <a:lstStyle/>
+          <a:p>
+            <a:pPr algn="ctr"/>
+            <a:r>
+              <a:rPr sz="1200" b="1">
+                <a:solidFill>
+                  <a:srgbClr val="FFFFFF"/>
+                </a:solidFill>
+                <a:latin typeface="Calibri"/>
+              </a:rPr>
+              <a:t>CORE SUPPORT</a:t>
+            </a:r>
+          </a:p>
+        </p:txBody>
+      </p:sp>
+      <p:sp>
+        <p:nvSpPr>
+          <p:cNvPr id="22" name="TextBox 21"/>
+          <p:cNvSpPr txBox="1"/>
+          <p:nvPr/>
+        </p:nvSpPr>
+        <p:spPr>
+          <a:xfrm>
+            <a:off x="4724247" y="1755648"/>
+            <a:ext cx="2743200" cy="274320"/>
+          </a:xfrm>
+          <a:prstGeom prst="rect">
+            <a:avLst/>
+          </a:prstGeom>
+          <a:noFill/>
+        </p:spPr>
+        <p:txBody>
+          <a:bodyPr wrap="square" anchor="t" lIns="45720" rIns="45720" tIns="18288" bIns="18288">
+            <a:spAutoFit/>
+          </a:bodyPr>
+          <a:lstStyle/>
+          <a:p>
+            <a:pPr algn="ctr"/>
+            <a:r>
+              <a:rPr sz="1100" b="1">
+                <a:solidFill>
+                  <a:srgbClr val="1F2A44"/>
+                </a:solidFill>
+                <a:latin typeface="Calibri"/>
+              </a:rPr>
+              <a:t>Enable &amp; Support</a:t>
+            </a:r>
+          </a:p>
+        </p:txBody>
+      </p:sp>
+      <p:sp>
+        <p:nvSpPr>
+          <p:cNvPr id="23" name="Rounded Rectangle 22"/>
+          <p:cNvSpPr/>
+          <p:nvPr/>
+        </p:nvSpPr>
+        <p:spPr>
+          <a:xfrm>
+            <a:off x="274320" y="3383280"/>
+            <a:ext cx="1554480" cy="411480"/>
+          </a:xfrm>
+          <a:prstGeom prst="roundRect">
+            <a:avLst/>
+          </a:prstGeom>
+          <a:solidFill>
+            <a:srgbClr val="0B2C5C"/>
+          </a:solidFill>
+          <a:ln>
+            <a:noFill/>
+          </a:ln>
+          <a:effectLst/>
+        </p:spPr>
+        <p:style>
+          <a:lnRef idx="1">
+            <a:schemeClr val="accent1"/>
+          </a:lnRef>
+          <a:fillRef idx="3">
+            <a:schemeClr val="accent1"/>
+          </a:fillRef>
+          <a:effectRef idx="2">
+            <a:schemeClr val="accent1"/>
+          </a:effectRef>
+          <a:fontRef idx="minor">
+            <a:schemeClr val="lt1"/>
+          </a:fontRef>
+        </p:style>
+        <p:txBody>
+          <a:bodyPr rtlCol="0" anchor="ctr" lIns="73152" rIns="73152" tIns="36576" bIns="36576"/>
+          <a:lstStyle/>
+          <a:p>
+            <a:pPr algn="ctr"/>
+            <a:r>
+              <a:rPr sz="1200" b="1">
+                <a:solidFill>
+                  <a:srgbClr val="FFFFFF"/>
+                </a:solidFill>
+                <a:latin typeface="Calibri"/>
+              </a:rPr>
+              <a:t>EXECUTION</a:t>
+            </a:r>
+          </a:p>
+        </p:txBody>
+      </p:sp>
+      <p:sp>
+        <p:nvSpPr>
+          <p:cNvPr id="24" name="TextBox 23"/>
+          <p:cNvSpPr txBox="1"/>
+          <p:nvPr/>
+        </p:nvSpPr>
+        <p:spPr>
+          <a:xfrm>
+            <a:off x="182880" y="3822191"/>
+            <a:ext cx="1737360" cy="594360"/>
+          </a:xfrm>
+          <a:prstGeom prst="rect">
+            <a:avLst/>
+          </a:prstGeom>
+          <a:noFill/>
+        </p:spPr>
+        <p:txBody>
+          <a:bodyPr wrap="square" anchor="t" lIns="45720" rIns="45720" tIns="18288" bIns="18288">
+            <a:spAutoFit/>
+          </a:bodyPr>
+          <a:lstStyle/>
+          <a:p>
+            <a:pPr algn="ctr"/>
+            <a:r>
+              <a:rPr sz="1000" b="0">
+                <a:solidFill>
+                  <a:srgbClr val="555F73"/>
+                </a:solidFill>
+                <a:latin typeface="Calibri"/>
+              </a:rPr>
+              <a:t>Plan &amp; Manage
+Deliver &amp; Execute</a:t>
+            </a:r>
+          </a:p>
+        </p:txBody>
+      </p:sp>
+      <p:sp>
+        <p:nvSpPr>
+          <p:cNvPr id="25" name="Rectangle 24"/>
+          <p:cNvSpPr/>
+          <p:nvPr/>
+        </p:nvSpPr>
+        <p:spPr>
+          <a:xfrm>
+            <a:off x="1828800" y="3584448"/>
+            <a:ext cx="2392528" cy="9000"/>
+          </a:xfrm>
+          <a:prstGeom prst="rect">
+            <a:avLst/>
+          </a:prstGeom>
+          <a:solidFill>
+            <a:srgbClr val="124A9C"/>
+          </a:solidFill>
+          <a:ln>
+            <a:noFill/>
+          </a:ln>
+          <a:effectLst/>
+        </p:spPr>
+        <p:style>
+          <a:lnRef idx="1">
+            <a:schemeClr val="accent1"/>
+          </a:lnRef>
+          <a:fillRef idx="3">
+            <a:schemeClr val="accent1"/>
+          </a:fillRef>
+          <a:effectRef idx="2">
+            <a:schemeClr val="accent1"/>
+          </a:effectRef>
+          <a:fontRef idx="minor">
+            <a:schemeClr val="lt1"/>
+          </a:fontRef>
+        </p:style>
+        <p:txBody>
+          <a:bodyPr rtlCol="0" anchor="ctr"/>
+          <a:lstStyle/>
+          <a:p>
+            <a:pPr algn="ctr"/>
+          </a:p>
+        </p:txBody>
+      </p:sp>
+      <p:sp>
+        <p:nvSpPr>
+          <p:cNvPr id="26" name="Oval 25"/>
+          <p:cNvSpPr/>
+          <p:nvPr/>
+        </p:nvSpPr>
+        <p:spPr>
+          <a:xfrm>
+            <a:off x="4157320" y="3529584"/>
+            <a:ext cx="128016" cy="128016"/>
+          </a:xfrm>
+          <a:prstGeom prst="ellipse">
+            <a:avLst/>
+          </a:prstGeom>
+          <a:solidFill>
+            <a:srgbClr val="124A9C"/>
+          </a:solidFill>
+          <a:ln>
+            <a:noFill/>
+          </a:ln>
+          <a:effectLst/>
+        </p:spPr>
+        <p:style>
+          <a:lnRef idx="1">
+            <a:schemeClr val="accent1"/>
+          </a:lnRef>
+          <a:fillRef idx="3">
+            <a:schemeClr val="accent1"/>
+          </a:fillRef>
+          <a:effectRef idx="2">
+            <a:schemeClr val="accent1"/>
+          </a:effectRef>
+          <a:fontRef idx="minor">
+            <a:schemeClr val="lt1"/>
+          </a:fontRef>
+        </p:style>
+        <p:txBody>
+          <a:bodyPr rtlCol="0" anchor="ctr"/>
+          <a:lstStyle/>
+          <a:p>
+            <a:pPr algn="ctr"/>
+          </a:p>
+        </p:txBody>
+      </p:sp>
+      <p:sp>
+        <p:nvSpPr>
+          <p:cNvPr id="27" name="Rounded Rectangle 26"/>
+          <p:cNvSpPr/>
+          <p:nvPr/>
+        </p:nvSpPr>
+        <p:spPr>
+          <a:xfrm>
+            <a:off x="10362895" y="3383280"/>
+            <a:ext cx="1554480" cy="411480"/>
+          </a:xfrm>
+          <a:prstGeom prst="roundRect">
+            <a:avLst/>
+          </a:prstGeom>
+          <a:solidFill>
+            <a:srgbClr val="4A90D9"/>
+          </a:solidFill>
+          <a:ln>
+            <a:noFill/>
+          </a:ln>
+          <a:effectLst/>
+        </p:spPr>
+        <p:style>
+          <a:lnRef idx="1">
+            <a:schemeClr val="accent1"/>
+          </a:lnRef>
+          <a:fillRef idx="3">
+            <a:schemeClr val="accent1"/>
+          </a:fillRef>
+          <a:effectRef idx="2">
+            <a:schemeClr val="accent1"/>
+          </a:effectRef>
+          <a:fontRef idx="minor">
+            <a:schemeClr val="lt1"/>
+          </a:fontRef>
+        </p:style>
+        <p:txBody>
+          <a:bodyPr rtlCol="0" anchor="ctr" lIns="73152" rIns="73152" tIns="36576" bIns="36576"/>
+          <a:lstStyle/>
+          <a:p>
+            <a:pPr algn="ctr"/>
+            <a:r>
+              <a:rPr sz="1200" b="1">
+                <a:solidFill>
+                  <a:srgbClr val="FFFFFF"/>
+                </a:solidFill>
+                <a:latin typeface="Calibri"/>
+              </a:rPr>
+              <a:t>BUSINESS</a:t>
+            </a:r>
+          </a:p>
+        </p:txBody>
+      </p:sp>
+      <p:sp>
+        <p:nvSpPr>
+          <p:cNvPr id="28" name="TextBox 27"/>
+          <p:cNvSpPr txBox="1"/>
+          <p:nvPr/>
+        </p:nvSpPr>
+        <p:spPr>
+          <a:xfrm>
+            <a:off x="10271455" y="3822191"/>
+            <a:ext cx="1737360" cy="594360"/>
+          </a:xfrm>
+          <a:prstGeom prst="rect">
+            <a:avLst/>
+          </a:prstGeom>
+          <a:noFill/>
+        </p:spPr>
+        <p:txBody>
+          <a:bodyPr wrap="square" anchor="t" lIns="45720" rIns="45720" tIns="18288" bIns="18288">
+            <a:spAutoFit/>
+          </a:bodyPr>
+          <a:lstStyle/>
+          <a:p>
+            <a:pPr algn="ctr"/>
+            <a:r>
+              <a:rPr sz="1000" b="0">
+                <a:solidFill>
+                  <a:srgbClr val="555F73"/>
+                </a:solidFill>
+                <a:latin typeface="Calibri"/>
+              </a:rPr>
+              <a:t>Connect &amp; Serve
+Create Customer Value</a:t>
+            </a:r>
+          </a:p>
+        </p:txBody>
+      </p:sp>
+      <p:sp>
+        <p:nvSpPr>
+          <p:cNvPr id="29" name="Rectangle 28"/>
+          <p:cNvSpPr/>
+          <p:nvPr/>
+        </p:nvSpPr>
+        <p:spPr>
+          <a:xfrm>
+            <a:off x="7970366" y="3584448"/>
+            <a:ext cx="2392528" cy="9000"/>
+          </a:xfrm>
+          <a:prstGeom prst="rect">
+            <a:avLst/>
+          </a:prstGeom>
+          <a:solidFill>
+            <a:srgbClr val="4A90D9"/>
+          </a:solidFill>
+          <a:ln>
+            <a:noFill/>
+          </a:ln>
+          <a:effectLst/>
+        </p:spPr>
+        <p:style>
+          <a:lnRef idx="1">
+            <a:schemeClr val="accent1"/>
+          </a:lnRef>
+          <a:fillRef idx="3">
+            <a:schemeClr val="accent1"/>
+          </a:fillRef>
+          <a:effectRef idx="2">
+            <a:schemeClr val="accent1"/>
+          </a:effectRef>
+          <a:fontRef idx="minor">
+            <a:schemeClr val="lt1"/>
+          </a:fontRef>
+        </p:style>
+        <p:txBody>
+          <a:bodyPr rtlCol="0" anchor="ctr"/>
+          <a:lstStyle/>
+          <a:p>
+            <a:pPr algn="ctr"/>
+          </a:p>
+        </p:txBody>
+      </p:sp>
+      <p:sp>
+        <p:nvSpPr>
+          <p:cNvPr id="30" name="Oval 29"/>
+          <p:cNvSpPr/>
+          <p:nvPr/>
+        </p:nvSpPr>
+        <p:spPr>
+          <a:xfrm>
+            <a:off x="7906358" y="3529584"/>
+            <a:ext cx="128016" cy="128016"/>
+          </a:xfrm>
+          <a:prstGeom prst="ellipse">
+            <a:avLst/>
+          </a:prstGeom>
+          <a:solidFill>
+            <a:srgbClr val="4A90D9"/>
+          </a:solidFill>
+          <a:ln>
+            <a:noFill/>
+          </a:ln>
+          <a:effectLst/>
+        </p:spPr>
+        <p:style>
+          <a:lnRef idx="1">
+            <a:schemeClr val="accent1"/>
+          </a:lnRef>
+          <a:fillRef idx="3">
+            <a:schemeClr val="accent1"/>
+          </a:fillRef>
+          <a:effectRef idx="2">
+            <a:schemeClr val="accent1"/>
+          </a:effectRef>
+          <a:fontRef idx="minor">
+            <a:schemeClr val="lt1"/>
+          </a:fontRef>
+        </p:style>
+        <p:txBody>
+          <a:bodyPr rtlCol="0" anchor="ctr"/>
+          <a:lstStyle/>
+          <a:p>
+            <a:pPr algn="ctr"/>
+          </a:p>
+        </p:txBody>
+      </p:sp>
+      <p:sp>
+        <p:nvSpPr>
+          <p:cNvPr id="31" name="Rectangle 30"/>
+          <p:cNvSpPr/>
+          <p:nvPr/>
+        </p:nvSpPr>
+        <p:spPr>
+          <a:xfrm>
+            <a:off x="365760" y="5577840"/>
+            <a:ext cx="11460175" cy="1051560"/>
+          </a:xfrm>
+          <a:prstGeom prst="rect">
+            <a:avLst/>
+          </a:prstGeom>
+          <a:solidFill>
+            <a:srgbClr val="E9F1FA"/>
+          </a:solidFill>
+          <a:ln w="9525">
+            <a:solidFill>
+              <a:srgbClr val="BFD8EF"/>
+            </a:solidFill>
+          </a:ln>
+          <a:effectLst/>
+        </p:spPr>
+        <p:style>
+          <a:lnRef idx="1">
+            <a:schemeClr val="accent1"/>
+          </a:lnRef>
+          <a:fillRef idx="3">
+            <a:schemeClr val="accent1"/>
+          </a:fillRef>
+          <a:effectRef idx="2">
+            <a:schemeClr val="accent1"/>
+          </a:effectRef>
+          <a:fontRef idx="minor">
+            <a:schemeClr val="lt1"/>
+          </a:fontRef>
+        </p:style>
+        <p:txBody>
+          <a:bodyPr rtlCol="0" anchor="ctr"/>
+          <a:lstStyle/>
+          <a:p>
+            <a:pPr algn="ctr"/>
+          </a:p>
+        </p:txBody>
+      </p:sp>
+      <p:sp>
+        <p:nvSpPr>
+          <p:cNvPr id="32" name="TextBox 31"/>
+          <p:cNvSpPr txBox="1"/>
+          <p:nvPr/>
+        </p:nvSpPr>
+        <p:spPr>
+          <a:xfrm>
+            <a:off x="365760" y="5623560"/>
+            <a:ext cx="11460175" cy="274320"/>
+          </a:xfrm>
+          <a:prstGeom prst="rect">
+            <a:avLst/>
+          </a:prstGeom>
+          <a:noFill/>
+        </p:spPr>
+        <p:txBody>
+          <a:bodyPr wrap="square" anchor="t" lIns="45720" rIns="45720" tIns="18288" bIns="18288">
+            <a:spAutoFit/>
+          </a:bodyPr>
+          <a:lstStyle/>
+          <a:p>
+            <a:pPr algn="ctr"/>
+            <a:r>
+              <a:rPr sz="1300" b="1">
+                <a:solidFill>
+                  <a:srgbClr val="0B2C5C"/>
+                </a:solidFill>
+                <a:latin typeface="Calibri"/>
+              </a:rPr>
+              <a:t>Global Collaboration Network</a:t>
+            </a:r>
+          </a:p>
+        </p:txBody>
+      </p:sp>
+      <p:sp>
+        <p:nvSpPr>
+          <p:cNvPr id="33" name="Oval 32"/>
+          <p:cNvSpPr/>
+          <p:nvPr/>
+        </p:nvSpPr>
+        <p:spPr>
+          <a:xfrm>
+            <a:off x="1365473" y="5870448"/>
+            <a:ext cx="292608" cy="292608"/>
+          </a:xfrm>
+          <a:prstGeom prst="ellipse">
+            <a:avLst/>
+          </a:prstGeom>
+          <a:solidFill>
+            <a:srgbClr val="C8102E"/>
+          </a:solidFill>
+          <a:ln w="12700">
+            <a:solidFill>
+              <a:srgbClr val="FFFFFF"/>
+            </a:solidFill>
+          </a:ln>
+          <a:effectLst/>
+        </p:spPr>
+        <p:style>
+          <a:lnRef idx="1">
+            <a:schemeClr val="accent1"/>
+          </a:lnRef>
+          <a:fillRef idx="3">
+            <a:schemeClr val="accent1"/>
+          </a:fillRef>
+          <a:effectRef idx="2">
+            <a:schemeClr val="accent1"/>
+          </a:effectRef>
+          <a:fontRef idx="minor">
+            <a:schemeClr val="lt1"/>
+          </a:fontRef>
+        </p:style>
+        <p:txBody>
+          <a:bodyPr rtlCol="0" anchor="ctr" lIns="0" rIns="0" tIns="0" bIns="0"/>
+          <a:lstStyle/>
+          <a:p>
+            <a:pPr algn="ctr"/>
+            <a:r>
+              <a:rPr sz="900" b="1">
+                <a:solidFill>
+                  <a:srgbClr val="FFFFFF"/>
+                </a:solidFill>
+              </a:rPr>
+              <a:t>TW</a:t>
+            </a:r>
+          </a:p>
+        </p:txBody>
+      </p:sp>
+      <p:sp>
+        <p:nvSpPr>
+          <p:cNvPr id="34" name="TextBox 33"/>
+          <p:cNvSpPr txBox="1"/>
+          <p:nvPr/>
+        </p:nvSpPr>
+        <p:spPr>
+          <a:xfrm>
+            <a:off x="365760" y="6217920"/>
+            <a:ext cx="2292035" cy="201168"/>
+          </a:xfrm>
+          <a:prstGeom prst="rect">
+            <a:avLst/>
+          </a:prstGeom>
+          <a:noFill/>
+        </p:spPr>
+        <p:txBody>
+          <a:bodyPr wrap="square" anchor="t" lIns="45720" rIns="45720" tIns="18288" bIns="18288">
+            <a:spAutoFit/>
+          </a:bodyPr>
+          <a:lstStyle/>
+          <a:p>
+            <a:pPr algn="ctr"/>
+            <a:r>
+              <a:rPr sz="1000" b="1">
+                <a:solidFill>
+                  <a:srgbClr val="0B2C5C"/>
+                </a:solidFill>
+                <a:latin typeface="Calibri"/>
+              </a:rPr>
+              <a:t>Taiwan (HQ)</a:t>
+            </a:r>
+          </a:p>
+        </p:txBody>
+      </p:sp>
+      <p:sp>
+        <p:nvSpPr>
+          <p:cNvPr id="35" name="TextBox 34"/>
+          <p:cNvSpPr txBox="1"/>
+          <p:nvPr/>
+        </p:nvSpPr>
+        <p:spPr>
+          <a:xfrm>
+            <a:off x="411480" y="6400800"/>
+            <a:ext cx="2200595" cy="365760"/>
+          </a:xfrm>
+          <a:prstGeom prst="rect">
+            <a:avLst/>
+          </a:prstGeom>
+          <a:noFill/>
+        </p:spPr>
+        <p:txBody>
+          <a:bodyPr wrap="square" anchor="t" lIns="45720" rIns="45720" tIns="18288" bIns="18288">
+            <a:spAutoFit/>
+          </a:bodyPr>
+          <a:lstStyle/>
+          <a:p>
+            <a:pPr algn="ctr"/>
+            <a:r>
+              <a:rPr sz="800" b="0">
+                <a:solidFill>
+                  <a:srgbClr val="555F73"/>
+                </a:solidFill>
+                <a:latin typeface="Calibri"/>
+              </a:rPr>
+              <a:t>Project Leadership
+&amp; Coordination</a:t>
+            </a:r>
+          </a:p>
+        </p:txBody>
+      </p:sp>
+      <p:sp>
+        <p:nvSpPr>
+          <p:cNvPr id="36" name="Oval 35"/>
+          <p:cNvSpPr/>
+          <p:nvPr/>
+        </p:nvSpPr>
+        <p:spPr>
+          <a:xfrm>
+            <a:off x="3657508" y="5870448"/>
+            <a:ext cx="292608" cy="292608"/>
+          </a:xfrm>
+          <a:prstGeom prst="ellipse">
+            <a:avLst/>
+          </a:prstGeom>
+          <a:solidFill>
+            <a:srgbClr val="BC002D"/>
+          </a:solidFill>
+          <a:ln w="12700">
+            <a:solidFill>
+              <a:srgbClr val="FFFFFF"/>
+            </a:solidFill>
+          </a:ln>
+          <a:effectLst/>
+        </p:spPr>
+        <p:style>
+          <a:lnRef idx="1">
+            <a:schemeClr val="accent1"/>
+          </a:lnRef>
+          <a:fillRef idx="3">
+            <a:schemeClr val="accent1"/>
+          </a:fillRef>
+          <a:effectRef idx="2">
+            <a:schemeClr val="accent1"/>
+          </a:effectRef>
+          <a:fontRef idx="minor">
+            <a:schemeClr val="lt1"/>
+          </a:fontRef>
+        </p:style>
+        <p:txBody>
+          <a:bodyPr rtlCol="0" anchor="ctr" lIns="0" rIns="0" tIns="0" bIns="0"/>
+          <a:lstStyle/>
+          <a:p>
+            <a:pPr algn="ctr"/>
+            <a:r>
+              <a:rPr sz="900" b="1">
+                <a:solidFill>
+                  <a:srgbClr val="FFFFFF"/>
+                </a:solidFill>
+              </a:rPr>
+              <a:t>JP</a:t>
+            </a:r>
+          </a:p>
+        </p:txBody>
+      </p:sp>
+      <p:sp>
+        <p:nvSpPr>
+          <p:cNvPr id="37" name="TextBox 36"/>
+          <p:cNvSpPr txBox="1"/>
+          <p:nvPr/>
+        </p:nvSpPr>
+        <p:spPr>
+          <a:xfrm>
+            <a:off x="2657795" y="6217920"/>
+            <a:ext cx="2292035" cy="201168"/>
+          </a:xfrm>
+          <a:prstGeom prst="rect">
+            <a:avLst/>
+          </a:prstGeom>
+          <a:noFill/>
+        </p:spPr>
+        <p:txBody>
+          <a:bodyPr wrap="square" anchor="t" lIns="45720" rIns="45720" tIns="18288" bIns="18288">
+            <a:spAutoFit/>
+          </a:bodyPr>
+          <a:lstStyle/>
+          <a:p>
+            <a:pPr algn="ctr"/>
+            <a:r>
+              <a:rPr sz="1000" b="1">
+                <a:solidFill>
+                  <a:srgbClr val="0B2C5C"/>
+                </a:solidFill>
+                <a:latin typeface="Calibri"/>
+              </a:rPr>
+              <a:t>Japan (Site)</a:t>
+            </a:r>
+          </a:p>
+        </p:txBody>
+      </p:sp>
+      <p:sp>
+        <p:nvSpPr>
+          <p:cNvPr id="38" name="TextBox 37"/>
+          <p:cNvSpPr txBox="1"/>
+          <p:nvPr/>
+        </p:nvSpPr>
+        <p:spPr>
+          <a:xfrm>
+            <a:off x="2703515" y="6400800"/>
+            <a:ext cx="2200595" cy="365760"/>
+          </a:xfrm>
+          <a:prstGeom prst="rect">
+            <a:avLst/>
+          </a:prstGeom>
+          <a:noFill/>
+        </p:spPr>
+        <p:txBody>
+          <a:bodyPr wrap="square" anchor="t" lIns="45720" rIns="45720" tIns="18288" bIns="18288">
+            <a:spAutoFit/>
+          </a:bodyPr>
+          <a:lstStyle/>
+          <a:p>
+            <a:pPr algn="ctr"/>
+            <a:r>
+              <a:rPr sz="800" b="0">
+                <a:solidFill>
+                  <a:srgbClr val="555F73"/>
+                </a:solidFill>
+                <a:latin typeface="Calibri"/>
+              </a:rPr>
+              <a:t>Advanced Support
+&amp; Service</a:t>
+            </a:r>
+          </a:p>
+        </p:txBody>
+      </p:sp>
+      <p:sp>
+        <p:nvSpPr>
+          <p:cNvPr id="39" name="Oval 38"/>
+          <p:cNvSpPr/>
+          <p:nvPr/>
+        </p:nvSpPr>
+        <p:spPr>
+          <a:xfrm>
+            <a:off x="5949543" y="5870448"/>
+            <a:ext cx="292608" cy="292608"/>
+          </a:xfrm>
+          <a:prstGeom prst="ellipse">
+            <a:avLst/>
+          </a:prstGeom>
+          <a:solidFill>
+            <a:srgbClr val="FFCE00"/>
+          </a:solidFill>
+          <a:ln w="12700">
+            <a:solidFill>
+              <a:srgbClr val="FFFFFF"/>
+            </a:solidFill>
+          </a:ln>
+          <a:effectLst/>
+        </p:spPr>
+        <p:style>
+          <a:lnRef idx="1">
+            <a:schemeClr val="accent1"/>
+          </a:lnRef>
+          <a:fillRef idx="3">
+            <a:schemeClr val="accent1"/>
+          </a:fillRef>
+          <a:effectRef idx="2">
+            <a:schemeClr val="accent1"/>
+          </a:effectRef>
+          <a:fontRef idx="minor">
+            <a:schemeClr val="lt1"/>
+          </a:fontRef>
+        </p:style>
+        <p:txBody>
+          <a:bodyPr rtlCol="0" anchor="ctr" lIns="0" rIns="0" tIns="0" bIns="0"/>
+          <a:lstStyle/>
+          <a:p>
+            <a:pPr algn="ctr"/>
+            <a:r>
+              <a:rPr sz="900" b="1">
+                <a:solidFill>
+                  <a:srgbClr val="FFFFFF"/>
+                </a:solidFill>
+              </a:rPr>
+              <a:t>DE</a:t>
+            </a:r>
+          </a:p>
+        </p:txBody>
+      </p:sp>
+      <p:sp>
+        <p:nvSpPr>
+          <p:cNvPr id="40" name="TextBox 39"/>
+          <p:cNvSpPr txBox="1"/>
+          <p:nvPr/>
+        </p:nvSpPr>
+        <p:spPr>
+          <a:xfrm>
+            <a:off x="4949830" y="6217920"/>
+            <a:ext cx="2292035" cy="201168"/>
+          </a:xfrm>
+          <a:prstGeom prst="rect">
+            <a:avLst/>
+          </a:prstGeom>
+          <a:noFill/>
+        </p:spPr>
+        <p:txBody>
+          <a:bodyPr wrap="square" anchor="t" lIns="45720" rIns="45720" tIns="18288" bIns="18288">
+            <a:spAutoFit/>
+          </a:bodyPr>
+          <a:lstStyle/>
+          <a:p>
+            <a:pPr algn="ctr"/>
+            <a:r>
+              <a:rPr sz="1000" b="1">
+                <a:solidFill>
+                  <a:srgbClr val="0B2C5C"/>
+                </a:solidFill>
+                <a:latin typeface="Calibri"/>
+              </a:rPr>
+              <a:t>Germany (Engineering)</a:t>
+            </a:r>
+          </a:p>
+        </p:txBody>
+      </p:sp>
+      <p:sp>
+        <p:nvSpPr>
+          <p:cNvPr id="41" name="TextBox 40"/>
+          <p:cNvSpPr txBox="1"/>
+          <p:nvPr/>
+        </p:nvSpPr>
+        <p:spPr>
+          <a:xfrm>
+            <a:off x="4995550" y="6400800"/>
+            <a:ext cx="2200595" cy="365760"/>
+          </a:xfrm>
+          <a:prstGeom prst="rect">
+            <a:avLst/>
+          </a:prstGeom>
+          <a:noFill/>
+        </p:spPr>
+        <p:txBody>
+          <a:bodyPr wrap="square" anchor="t" lIns="45720" rIns="45720" tIns="18288" bIns="18288">
+            <a:spAutoFit/>
+          </a:bodyPr>
+          <a:lstStyle/>
+          <a:p>
+            <a:pPr algn="ctr"/>
+            <a:r>
+              <a:rPr sz="800" b="0">
+                <a:solidFill>
+                  <a:srgbClr val="555F73"/>
+                </a:solidFill>
+                <a:latin typeface="Calibri"/>
+              </a:rPr>
+              <a:t>Engineering Excellence
+&amp; Innovation</a:t>
+            </a:r>
+          </a:p>
+        </p:txBody>
+      </p:sp>
+      <p:sp>
+        <p:nvSpPr>
+          <p:cNvPr id="42" name="Oval 41"/>
+          <p:cNvSpPr/>
+          <p:nvPr/>
+        </p:nvSpPr>
+        <p:spPr>
+          <a:xfrm>
+            <a:off x="8241578" y="5870448"/>
+            <a:ext cx="292608" cy="292608"/>
+          </a:xfrm>
+          <a:prstGeom prst="ellipse">
+            <a:avLst/>
+          </a:prstGeom>
+          <a:solidFill>
+            <a:srgbClr val="3C3B6E"/>
+          </a:solidFill>
+          <a:ln w="12700">
+            <a:solidFill>
+              <a:srgbClr val="FFFFFF"/>
+            </a:solidFill>
+          </a:ln>
+          <a:effectLst/>
+        </p:spPr>
+        <p:style>
+          <a:lnRef idx="1">
+            <a:schemeClr val="accent1"/>
+          </a:lnRef>
+          <a:fillRef idx="3">
+            <a:schemeClr val="accent1"/>
+          </a:fillRef>
+          <a:effectRef idx="2">
+            <a:schemeClr val="accent1"/>
+          </a:effectRef>
+          <a:fontRef idx="minor">
+            <a:schemeClr val="lt1"/>
+          </a:fontRef>
+        </p:style>
+        <p:txBody>
+          <a:bodyPr rtlCol="0" anchor="ctr" lIns="0" rIns="0" tIns="0" bIns="0"/>
+          <a:lstStyle/>
+          <a:p>
+            <a:pPr algn="ctr"/>
+            <a:r>
+              <a:rPr sz="900" b="1">
+                <a:solidFill>
+                  <a:srgbClr val="FFFFFF"/>
+                </a:solidFill>
+              </a:rPr>
+              <a:t>US</a:t>
+            </a:r>
+          </a:p>
+        </p:txBody>
+      </p:sp>
+      <p:sp>
+        <p:nvSpPr>
+          <p:cNvPr id="43" name="TextBox 42"/>
+          <p:cNvSpPr txBox="1"/>
+          <p:nvPr/>
+        </p:nvSpPr>
+        <p:spPr>
+          <a:xfrm>
+            <a:off x="7241865" y="6217920"/>
+            <a:ext cx="2292035" cy="201168"/>
+          </a:xfrm>
+          <a:prstGeom prst="rect">
+            <a:avLst/>
+          </a:prstGeom>
+          <a:noFill/>
+        </p:spPr>
+        <p:txBody>
+          <a:bodyPr wrap="square" anchor="t" lIns="45720" rIns="45720" tIns="18288" bIns="18288">
+            <a:spAutoFit/>
+          </a:bodyPr>
+          <a:lstStyle/>
+          <a:p>
+            <a:pPr algn="ctr"/>
+            <a:r>
+              <a:rPr sz="1000" b="1">
+                <a:solidFill>
+                  <a:srgbClr val="0B2C5C"/>
+                </a:solidFill>
+                <a:latin typeface="Calibri"/>
+              </a:rPr>
+              <a:t>USA (Support)</a:t>
+            </a:r>
+          </a:p>
+        </p:txBody>
+      </p:sp>
+      <p:sp>
+        <p:nvSpPr>
+          <p:cNvPr id="44" name="TextBox 43"/>
+          <p:cNvSpPr txBox="1"/>
+          <p:nvPr/>
+        </p:nvSpPr>
+        <p:spPr>
+          <a:xfrm>
+            <a:off x="7287585" y="6400800"/>
+            <a:ext cx="2200595" cy="365760"/>
+          </a:xfrm>
+          <a:prstGeom prst="rect">
+            <a:avLst/>
+          </a:prstGeom>
+          <a:noFill/>
+        </p:spPr>
+        <p:txBody>
+          <a:bodyPr wrap="square" anchor="t" lIns="45720" rIns="45720" tIns="18288" bIns="18288">
+            <a:spAutoFit/>
+          </a:bodyPr>
+          <a:lstStyle/>
+          <a:p>
+            <a:pPr algn="ctr"/>
+            <a:r>
+              <a:rPr sz="800" b="0">
+                <a:solidFill>
+                  <a:srgbClr val="555F73"/>
+                </a:solidFill>
+                <a:latin typeface="Calibri"/>
+              </a:rPr>
+              <a:t>Technical Support
+&amp; Solutions</a:t>
+            </a:r>
+          </a:p>
+        </p:txBody>
+      </p:sp>
+      <p:sp>
+        <p:nvSpPr>
+          <p:cNvPr id="45" name="Oval 44"/>
+          <p:cNvSpPr/>
+          <p:nvPr/>
+        </p:nvSpPr>
+        <p:spPr>
+          <a:xfrm>
+            <a:off x="10533613" y="5870448"/>
+            <a:ext cx="292608" cy="292608"/>
+          </a:xfrm>
+          <a:prstGeom prst="ellipse">
+            <a:avLst/>
+          </a:prstGeom>
+          <a:solidFill>
+            <a:srgbClr val="DE2910"/>
+          </a:solidFill>
+          <a:ln w="12700">
+            <a:solidFill>
+              <a:srgbClr val="FFFFFF"/>
+            </a:solidFill>
+          </a:ln>
+          <a:effectLst/>
+        </p:spPr>
+        <p:style>
+          <a:lnRef idx="1">
+            <a:schemeClr val="accent1"/>
+          </a:lnRef>
+          <a:fillRef idx="3">
+            <a:schemeClr val="accent1"/>
+          </a:fillRef>
+          <a:effectRef idx="2">
+            <a:schemeClr val="accent1"/>
+          </a:effectRef>
+          <a:fontRef idx="minor">
+            <a:schemeClr val="lt1"/>
+          </a:fontRef>
+        </p:style>
+        <p:txBody>
+          <a:bodyPr rtlCol="0" anchor="ctr" lIns="0" rIns="0" tIns="0" bIns="0"/>
+          <a:lstStyle/>
+          <a:p>
+            <a:pPr algn="ctr"/>
+            <a:r>
+              <a:rPr sz="900" b="1">
+                <a:solidFill>
+                  <a:srgbClr val="FFFFFF"/>
+                </a:solidFill>
+              </a:rPr>
+              <a:t>CN</a:t>
+            </a:r>
+          </a:p>
+        </p:txBody>
+      </p:sp>
+      <p:sp>
+        <p:nvSpPr>
+          <p:cNvPr id="46" name="TextBox 45"/>
+          <p:cNvSpPr txBox="1"/>
+          <p:nvPr/>
+        </p:nvSpPr>
+        <p:spPr>
+          <a:xfrm>
+            <a:off x="9533900" y="6217920"/>
+            <a:ext cx="2292035" cy="201168"/>
+          </a:xfrm>
+          <a:prstGeom prst="rect">
+            <a:avLst/>
+          </a:prstGeom>
+          <a:noFill/>
+        </p:spPr>
+        <p:txBody>
+          <a:bodyPr wrap="square" anchor="t" lIns="45720" rIns="45720" tIns="18288" bIns="18288">
+            <a:spAutoFit/>
+          </a:bodyPr>
+          <a:lstStyle/>
+          <a:p>
+            <a:pPr algn="ctr"/>
+            <a:r>
+              <a:rPr sz="1000" b="1">
+                <a:solidFill>
+                  <a:srgbClr val="0B2C5C"/>
+                </a:solidFill>
+                <a:latin typeface="Calibri"/>
+              </a:rPr>
+              <a:t>China (Manufacturing)</a:t>
+            </a:r>
+          </a:p>
+        </p:txBody>
+      </p:sp>
+      <p:sp>
+        <p:nvSpPr>
+          <p:cNvPr id="47" name="TextBox 46"/>
+          <p:cNvSpPr txBox="1"/>
+          <p:nvPr/>
+        </p:nvSpPr>
+        <p:spPr>
+          <a:xfrm>
+            <a:off x="9579620" y="6400800"/>
+            <a:ext cx="2200595" cy="365760"/>
+          </a:xfrm>
+          <a:prstGeom prst="rect">
+            <a:avLst/>
+          </a:prstGeom>
+          <a:noFill/>
+        </p:spPr>
+        <p:txBody>
+          <a:bodyPr wrap="square" anchor="t" lIns="45720" rIns="45720" tIns="18288" bIns="18288">
+            <a:spAutoFit/>
+          </a:bodyPr>
+          <a:lstStyle/>
+          <a:p>
+            <a:pPr algn="ctr"/>
+            <a:r>
+              <a:rPr sz="800" b="0">
+                <a:solidFill>
+                  <a:srgbClr val="555F73"/>
+                </a:solidFill>
+                <a:latin typeface="Calibri"/>
+              </a:rPr>
+              <a:t>Manufacturing Support
+&amp; Execution</a:t>
+            </a:r>
+          </a:p>
+        </p:txBody>
+      </p:sp>
+      <p:sp>
+        <p:nvSpPr>
+          <p:cNvPr id="48" name="TextBox 47"/>
+          <p:cNvSpPr txBox="1"/>
+          <p:nvPr/>
+        </p:nvSpPr>
+        <p:spPr>
+          <a:xfrm>
+            <a:off x="0" y="6492240"/>
+            <a:ext cx="12191695" cy="182880"/>
+          </a:xfrm>
+          <a:prstGeom prst="rect">
+            <a:avLst/>
+          </a:prstGeom>
+          <a:noFill/>
+        </p:spPr>
+        <p:txBody>
+          <a:bodyPr wrap="square" anchor="t" lIns="45720" rIns="45720" tIns="18288" bIns="18288">
+            <a:spAutoFit/>
+          </a:bodyPr>
+          <a:lstStyle/>
+          <a:p>
+            <a:pPr algn="ctr"/>
+            <a:r>
+              <a:rPr sz="900" b="0">
+                <a:solidFill>
+                  <a:srgbClr val="555F73"/>
                 </a:solidFill>
                 <a:latin typeface="Calibri"/>
               </a:rPr>

</xml_diff>